<commit_message>
chore: update 15factor presentation file
</commit_message>
<xml_diff>
--- a/15factor-presentation.pptx
+++ b/15factor-presentation.pptx
@@ -16439,7 +16439,7 @@
                 <a:ea typeface="Calibri" pitchFamily="34" charset="-122"/>
                 <a:cs typeface="Calibri" pitchFamily="34" charset="-120"/>
               </a:rPr>
-              <a:t>All 4 services in one mono-repo: SpringCloudLibraryPreAuthorized</a:t>
+              <a:t>5 repos under SWE455-proj-team: infra, user-service, book-service, api-gateway, eureka-server</a:t>
             </a:r>
             <a:endParaRPr lang="en-US" sz="1100" dirty="0"/>
           </a:p>
@@ -16481,7 +16481,7 @@
                 <a:ea typeface="Calibri" pitchFamily="34" charset="-122"/>
                 <a:cs typeface="Calibri" pitchFamily="34" charset="-120"/>
               </a:rPr>
-              <a:t>Each push to main triggers CI/CD — one source of truth</a:t>
+              <a:t>Each repo has its own GitHub Actions pipeline — independent CI/CD per service</a:t>
             </a:r>
             <a:endParaRPr lang="en-US" sz="1100" dirty="0"/>
           </a:p>
@@ -16545,7 +16545,7 @@
                 <a:ea typeface="Consolas" pitchFamily="34" charset="-122"/>
                 <a:cs typeface="Consolas" pitchFamily="34" charset="-120"/>
               </a:rPr>
-              <a:t>github.com/Jsploitt/SpringCloudLibraryPreAuthorized</a:t>
+              <a:t>github.com/SWE455-proj-team/{service-name}</a:t>
             </a:r>
             <a:endParaRPr lang="en-US" sz="950" dirty="0"/>
           </a:p>
@@ -16626,7 +16626,7 @@
                 <a:ea typeface="Calibri" pitchFamily="34" charset="-122"/>
                 <a:cs typeface="Calibri" pitchFamily="34" charset="-120"/>
               </a:rPr>
-              <a:t>✓  One repo, one pipeline, one version per deploy</a:t>
+              <a:t>✓  One repo per service — independent deploy, scale, and release cycle</a:t>
             </a:r>
             <a:endParaRPr lang="en-US" sz="1100" dirty="0"/>
           </a:p>

</xml_diff>